<commit_message>
LLM-authored policy achieves -6.76% electricity, -7.64% peak, PMV -0.391 to +0.14
Direction guard rejects any policy that lowers the cooling setpoint while occupied PMV is below -0.2, making the outcome robust to model sampling variance (identical runs previously spread 0.85-4.35%). Temperature 0 for reproducibility. Warm start deferred until occupied comfort data exists, so the first policy is made on evidence rather than a null PMV. commit_policy now requires all zones: a partial policy silently reverted omitted zones to the config default.
</commit_message>
<xml_diff>
--- a/deck/Eco-Loop_IDEA_Submission.pptx
+++ b/deck/Eco-Loop_IDEA_Submission.pptx
@@ -236,13 +236,13 @@
                 <c:formatCode>General</c:formatCode>
                 <c:ptCount val="4"/>
                 <c:pt idx="0">
-                  <c:v>5.08</c:v>
+                  <c:v>6.76</c:v>
                 </c:pt>
                 <c:pt idx="1">
-                  <c:v>4.83</c:v>
+                  <c:v>6.44</c:v>
                 </c:pt>
                 <c:pt idx="2">
-                  <c:v>5.8</c:v>
+                  <c:v>7.64</c:v>
                 </c:pt>
                 <c:pt idx="3">
                   <c:v>14.5</c:v>
@@ -5656,7 +5656,7 @@
                 <a:latin typeface="Arial" pitchFamily="34" charset="0"/>
                 <a:cs typeface="Arial" pitchFamily="34" charset="0"/>
               </a:rPr>
-              <a:t>Measured on a 7-day July A/B run:  -5.08% electricity   -5.80% peak demand   PMV -0.391 to +0.009</a:t>
+              <a:t>Measured, 7-day July A/B, LLM-authored policy:  -6.76% electricity   -7.64% peak demand   PMV -0.391 to +0.14</a:t>
             </a:r>
             <a:endParaRPr lang="en-US" sz="3200" u="sng" dirty="0">
               <a:latin typeface="Arial" pitchFamily="34" charset="0"/>
@@ -6999,14 +6999,14 @@
               <a:buNone/>
             </a:pPr>
             <a:r>
-              <a:rPr lang="en-US" sz="1200" dirty="0" b="0" i="1" u="none">
+              <a:rPr lang="en-US" sz="1100" dirty="0" b="0" i="1" u="none">
                 <a:solidFill>
                   <a:srgbClr val="556677"/>
                 </a:solidFill>
                 <a:latin typeface="Arial" pitchFamily="34" charset="0"/>
                 <a:cs typeface="Arial" pitchFamily="34" charset="0"/>
               </a:rPr>
-              <a:t>Identical model, identical weather. Only the controller differs.</a:t>
+              <a:t>Policy authored by the LLM (llama3.2:3b, local, temperature 0 so the run is reproducible). Identical model and weather; only the controller differs.</a:t>
             </a:r>
           </a:p>
           <a:p>
@@ -7035,7 +7035,7 @@
                 <a:latin typeface="Arial" pitchFamily="34" charset="0"/>
                 <a:cs typeface="Arial" pitchFamily="34" charset="0"/>
               </a:rPr>
-              <a:t>Electricity      1251.97  -&gt;  1188.40 kWh      -5.08%</a:t>
+              <a:t>Electricity      1251.97  -&gt;  1167.33 kWh      -6.76%</a:t>
             </a:r>
           </a:p>
           <a:p>
@@ -7064,7 +7064,7 @@
                 <a:latin typeface="Arial" pitchFamily="34" charset="0"/>
                 <a:cs typeface="Arial" pitchFamily="34" charset="0"/>
               </a:rPr>
-              <a:t>Total energy     1309.46  -&gt;  1246.20 kWh      -4.83%</a:t>
+              <a:t>Total energy     1309.46  -&gt;  1225.14 kWh      -6.44%</a:t>
             </a:r>
           </a:p>
           <a:p>
@@ -7093,7 +7093,7 @@
                 <a:latin typeface="Arial" pitchFamily="34" charset="0"/>
                 <a:cs typeface="Arial" pitchFamily="34" charset="0"/>
               </a:rPr>
-              <a:t>Peak demand        18.97  -&gt;    17.87 kW       -5.80%</a:t>
+              <a:t>Peak demand        18.97  -&gt;    17.52 kW       -7.64%</a:t>
             </a:r>
           </a:p>
           <a:p>
@@ -7151,7 +7151,7 @@
                 <a:latin typeface="Arial" pitchFamily="34" charset="0"/>
                 <a:cs typeface="Arial" pitchFamily="34" charset="0"/>
               </a:rPr>
-              <a:t>Mean PMV          -0.391  -&gt;   +0.009    band -0.5 to +0.5</a:t>
+              <a:t>Mean PMV          -0.391  -&gt;   +0.140    band -0.5 to +0.5</a:t>
             </a:r>
           </a:p>
           <a:p>
@@ -7209,7 +7209,7 @@
                 <a:latin typeface="Arial" pitchFamily="34" charset="0"/>
                 <a:cs typeface="Arial" pitchFamily="34" charset="0"/>
               </a:rPr>
-              <a:t>Unmet setpoint      0.00% -&gt;     0.72%   of occupied zone-hours</a:t>
+              <a:t>Unmet setpoint      0.00% -&gt;     0.60%   of occupied zone-hours</a:t>
             </a:r>
           </a:p>
           <a:p>
@@ -7231,43 +7231,14 @@
               <a:buNone/>
             </a:pPr>
             <a:r>
-              <a:rPr lang="en-US" sz="1000" dirty="0" b="0" i="1" u="none">
-                <a:solidFill>
-                  <a:srgbClr val="556677"/>
+              <a:rPr lang="en-US" sz="1100" dirty="0" b="0" i="1" u="none">
+                <a:solidFill>
+                  <a:srgbClr val="1E2B3A"/>
                 </a:solidFill>
                 <a:latin typeface="Arial" pitchFamily="34" charset="0"/>
                 <a:cs typeface="Arial" pitchFamily="34" charset="0"/>
               </a:rPr>
-              <a:t>Comfort figures are percentage points; energy figures are percentages.</a:t>
-            </a:r>
-          </a:p>
-          <a:p>
-            <a:pPr marL="342900" marR="0" indent="-342900" algn="just" defTabSz="457200" rtl="0" eaLnBrk="1" fontAlgn="base" latinLnBrk="0" hangingPunct="1">
-              <a:lnSpc>
-                <a:spcPct val="100000"/>
-              </a:lnSpc>
-              <a:spcBef>
-                <a:spcPct val="0"/>
-              </a:spcBef>
-              <a:spcAft>
-                <a:spcPts val="200"/>
-              </a:spcAft>
-              <a:buClrTx/>
-              <a:buSzTx/>
-              <a:buFont typeface="Arial" panose="020B0604020202020204" pitchFamily="34" charset="0"/>
-              <a:tabLst/>
-              <a:defRPr/>
-              <a:buNone/>
-            </a:pPr>
-            <a:r>
-              <a:rPr lang="en-US" sz="1100" dirty="0" b="0" i="1" u="none">
-                <a:solidFill>
-                  <a:srgbClr val="1E2B3A"/>
-                </a:solidFill>
-                <a:latin typeface="Arial" pitchFamily="34" charset="0"/>
-                <a:cs typeface="Arial" pitchFamily="34" charset="0"/>
-              </a:rPr>
-              <a:t>The stock schedule overcools (PMV -0.39), so raising the occupied cooling setpoint to 25.5 C saves energy AND moves comfort toward neutral - aligned, not in tension.</a:t>
+              <a:t>The stock schedule overcools (PMV -0.39), so raising the occupied cooling setpoint saves energy AND moves comfort toward neutral - aligned, not in tension. The agent beat a hand-tuned static policy (-5.08%) on the same model.</a:t>
             </a:r>
           </a:p>
           <a:p>

</xml_diff>

<commit_message>
Add PoC video link to README and deck; add dashboard screenshot conventions
</commit_message>
<xml_diff>
--- a/deck/Eco-Loop_IDEA_Submission.pptx
+++ b/deck/Eco-Loop_IDEA_Submission.pptx
@@ -7267,7 +7267,7 @@
                 <a:latin typeface="Arial" pitchFamily="34" charset="0"/>
                 <a:cs typeface="Arial" pitchFamily="34" charset="0"/>
               </a:rPr>
-              <a:t>Artifacts in the repository</a:t>
+              <a:t>Artifacts</a:t>
             </a:r>
           </a:p>
           <a:p>
@@ -7296,7 +7296,7 @@
                 <a:latin typeface="Arial" pitchFamily="34" charset="0"/>
                 <a:cs typeface="Arial" pitchFamily="34" charset="0"/>
               </a:rPr>
-              <a:t>Source, both .idf models, savings dashboard, architecture document, agent trace (tool calls, rejections, self-corrections), PoC video</a:t>
+              <a:t>Source, both .idf models + runtime policy snapshots, savings dashboard, architecture document, agent trace (tool calls, rejections, self-corrections)</a:t>
             </a:r>
           </a:p>
           <a:p>
@@ -7325,7 +7325,36 @@
                 <a:latin typeface="Arial" pitchFamily="34" charset="0"/>
                 <a:cs typeface="Arial" pitchFamily="34" charset="0"/>
               </a:rPr>
-              <a:t>github.com/DivyanshM30/eco-loop-building-agents</a:t>
+              <a:t>Repository:  github.com/DivyanshM30/eco-loop-building-agents</a:t>
+            </a:r>
+          </a:p>
+          <a:p>
+            <a:pPr marL="342900" marR="0" indent="-342900" algn="just" defTabSz="457200" rtl="0" eaLnBrk="1" fontAlgn="base" latinLnBrk="0" hangingPunct="1">
+              <a:lnSpc>
+                <a:spcPct val="100000"/>
+              </a:lnSpc>
+              <a:spcBef>
+                <a:spcPct val="0"/>
+              </a:spcBef>
+              <a:spcAft>
+                <a:spcPts val="200"/>
+              </a:spcAft>
+              <a:buClrTx/>
+              <a:buSzTx/>
+              <a:buFont typeface="Arial" panose="020B0604020202020204" pitchFamily="34" charset="0"/>
+              <a:tabLst/>
+              <a:defRPr/>
+              <a:buNone/>
+            </a:pPr>
+            <a:r>
+              <a:rPr lang="en-US" sz="1100" dirty="0" b="1" i="0" u="none">
+                <a:solidFill>
+                  <a:srgbClr val="2C5F2D"/>
+                </a:solidFill>
+                <a:latin typeface="Arial" pitchFamily="34" charset="0"/>
+                <a:cs typeface="Arial" pitchFamily="34" charset="0"/>
+              </a:rPr>
+              <a:t>PoC video (3 min):  drive.google.com/drive/folders/1BnIvuYQWBIXOHk3vVQ0LGkk2cF6vWLvq</a:t>
             </a:r>
           </a:p>
         </p:txBody>

</xml_diff>